<commit_message>
modified:   .gitignore 	deleted:    aws_todo.md 	new file:   how_secret_id_is_created.md 	modified:   identity_service/myrun.sh 	new file:   onboard-user-chain.html 	new file:   onboard-user-runbook.md 	modified:   openfga_postgres/ARCHITECTURE.md 	modified:   openfga_postgres/myrun.sh 	modified:   presentation/click-to-prism.html 	new file:   presentation/click-to-prismv0.html 	modified:   presentation/generate_deck.py 	modified:   presentation/libcloud_nutanix_system_overview.pptx 	new file:   presentation/libcloud_nutanix_system_overviewv0.pptx 	new file:   vault/APPROLE_INTERNALS.md 	modified:   vault/ARCHITECTURE.md 	modified:   vault/myrun.sh 	deleted:    vault_redesign.md
</commit_message>
<xml_diff>
--- a/presentation/libcloud_nutanix_system_overview.pptx
+++ b/presentation/libcloud_nutanix_system_overview.pptx
@@ -5594,7 +5594,7 @@
                 </a:solidFill>
                 <a:latin typeface="Calibri"/>
               </a:rPr>
-              <a:t>▪  OpenFGA v1.16.0, PostgreSQL-backed, 8 types on schema 1.1</a:t>
+              <a:t>▪  OpenFGA v1.16.0, PostgreSQL-backed, 9 types on schema 1.1</a:t>
             </a:r>
           </a:p>
           <a:p>
@@ -5616,7 +5616,7 @@
                 </a:solidFill>
                 <a:latin typeface="Calibri"/>
               </a:rPr>
-              <a:t>–  user · platform · tenant · libcloud_api · provider · resource_class · aws_region · nutanix_cluster</a:t>
+              <a:t>–  user · platform · tenant · libcloud_api · provider · resource_class · aws_region · nutanix_cluster · vault_user</a:t>
             </a:r>
           </a:p>
           <a:p>
@@ -5638,7 +5638,51 @@
                 </a:solidFill>
                 <a:latin typeface="Calibri"/>
               </a:rPr>
-              <a:t>–  Bootstrap seeds 48 tuples — 39 structural wiring + 9 role grants</a:t>
+              <a:t>–  Bootstrap seeds 50 tuples — 41 structural wiring + 9 role grants</a:t>
+            </a:r>
+          </a:p>
+          <a:p>
+            <a:pPr algn="l">
+              <a:lnSpc>
+                <a:spcPct val="122000"/>
+              </a:lnSpc>
+              <a:spcBef>
+                <a:spcPts val="900"/>
+              </a:spcBef>
+              <a:spcAft>
+                <a:spcPts val="300"/>
+              </a:spcAft>
+            </a:pPr>
+            <a:r>
+              <a:rPr sz="1650" b="1">
+                <a:solidFill>
+                  <a:srgbClr val="0F172A"/>
+                </a:solidFill>
+                <a:latin typeface="Calibri"/>
+              </a:rPr>
+              <a:t>▪  A new vault_user type maps each tenant to its Vault AppRole identity</a:t>
+            </a:r>
+          </a:p>
+          <a:p>
+            <a:pPr algn="l" lvl="1">
+              <a:lnSpc>
+                <a:spcPct val="122000"/>
+              </a:lnSpc>
+              <a:spcBef>
+                <a:spcPts val="200"/>
+              </a:spcBef>
+              <a:spcAft>
+                <a:spcPts val="300"/>
+              </a:spcAft>
+            </a:pPr>
+            <a:r>
+              <a:rPr sz="1400" b="0">
+                <a:solidFill>
+                  <a:srgbClr val="64748B"/>
+                </a:solidFill>
+                <a:latin typeface="Calibri"/>
+              </a:rPr>
+              <a:t>–  tenant:&lt;t&gt; parent vault_user:libcloud-&lt;t&gt; — the tenant's Vault user</a:t>
             </a:r>
           </a:p>
           <a:p>
@@ -11375,7 +11419,7 @@
                 </a:solidFill>
                 <a:latin typeface="Consolas"/>
               </a:rPr>
-              <a:t>GET /v1/secret/data/libcloud/aws   X-Vault-Token   (30 s cache)</a:t>
+              <a:t>resolve vault_user (OpenFGA) → AppRole material → AppRole login → read secret (60 m token, 30 s cache)</a:t>
             </a:r>
           </a:p>
         </p:txBody>
@@ -11590,7 +11634,7 @@
                 </a:solidFill>
                 <a:latin typeface="Calibri"/>
               </a:rPr>
-              <a:t>The client names which credential to use (auth_binding); it never supplies the value.</a:t>
+              <a:t>The client names auth_binding; the server resolves the tenant's Vault AppRole and fetches the value.</a:t>
             </a:r>
           </a:p>
         </p:txBody>
@@ -12008,6 +12052,28 @@
                 </a:solidFill>
                 <a:latin typeface="Calibri"/>
               </a:rPr>
+              <a:t>▪  Each tenant now gets its own Vault AppRole identity, mapped in OpenFGA</a:t>
+            </a:r>
+          </a:p>
+          <a:p>
+            <a:pPr algn="l">
+              <a:lnSpc>
+                <a:spcPct val="122000"/>
+              </a:lnSpc>
+              <a:spcBef>
+                <a:spcPts val="900"/>
+              </a:spcBef>
+              <a:spcAft>
+                <a:spcPts val="300"/>
+              </a:spcAft>
+            </a:pPr>
+            <a:r>
+              <a:rPr sz="1650" b="1">
+                <a:solidFill>
+                  <a:srgbClr val="0F172A"/>
+                </a:solidFill>
+                <a:latin typeface="Calibri"/>
+              </a:rPr>
               <a:t>▪  Five concerns are split across five services, deliberately</a:t>
             </a:r>
           </a:p>
@@ -12313,7 +12379,7 @@
                 </a:solidFill>
                 <a:latin typeface="Calibri"/>
               </a:rPr>
-              <a:t>▪  Vault 1.15, file storage backend, KV v2 mounted at secret/</a:t>
+              <a:t>▪  Vault 1.15, file storage, KV v2 at secret/ + AppRole auth at approle/</a:t>
             </a:r>
           </a:p>
           <a:p>
@@ -12335,7 +12401,7 @@
                 </a:solidFill>
                 <a:latin typeface="Calibri"/>
               </a:rPr>
-              <a:t>–  secret/data/libcloud/aws       → AWS access key / secret</a:t>
+              <a:t>–  Per-tenant cloud secret: secret/data/libcloud/&lt;tenant&gt;</a:t>
             </a:r>
           </a:p>
           <a:p>
@@ -12357,7 +12423,7 @@
                 </a:solidFill>
                 <a:latin typeface="Calibri"/>
               </a:rPr>
-              <a:t>–  secret/data/libcloud/nutanix   → Prism username / password</a:t>
+              <a:t>–  aws → access key / secret        nutanix → Prism username / password</a:t>
             </a:r>
           </a:p>
           <a:p>
@@ -12379,7 +12445,7 @@
                 </a:solidFill>
                 <a:latin typeface="Calibri"/>
               </a:rPr>
-              <a:t>▪  Writing a tenant credential is itself authorized</a:t>
+              <a:t>▪  Each tenant has its own Vault identity — an AppRole, not a shared token</a:t>
             </a:r>
           </a:p>
           <a:p>
@@ -12401,7 +12467,7 @@
                 </a:solidFill>
                 <a:latin typeface="Calibri"/>
               </a:rPr>
-              <a:t>–  The tenant owner logs into Dex, passes an OpenFGA can_manage_credentials check,</a:t>
+              <a:t>–  AppRole libcloud-&lt;tenant&gt;, policy libcloud-read-&lt;tenant&gt; (read only that tenant)</a:t>
             </a:r>
           </a:p>
           <a:p>
@@ -12423,7 +12489,7 @@
                 </a:solidFill>
                 <a:latin typeface="Calibri"/>
               </a:rPr>
-              <a:t>–  and only then writes to Vault</a:t>
+              <a:t>–  The tenant → vault-user mapping lives in OpenFGA (vault_user type)</a:t>
             </a:r>
           </a:p>
           <a:p>
@@ -12445,7 +12511,7 @@
                 </a:solidFill>
                 <a:latin typeface="Calibri"/>
               </a:rPr>
-              <a:t>▪  Reading happens server-side at provision time</a:t>
+              <a:t>▪  The single global read token is replaced by a narrow orchestrator token</a:t>
             </a:r>
           </a:p>
           <a:p>
@@ -12467,7 +12533,7 @@
                 </a:solidFill>
                 <a:latin typeface="Calibri"/>
               </a:rPr>
-              <a:t>–  libcloud.rest holds a scoped read token and caches values for 30 s</a:t>
+              <a:t>–  It can read AppRole auth material only — never the cloud secrets</a:t>
             </a:r>
           </a:p>
           <a:p>
@@ -12489,7 +12555,7 @@
                 </a:solidFill>
                 <a:latin typeface="Calibri"/>
               </a:rPr>
-              <a:t>–  Client-supplied credentials are rejected with 403 unless explicitly enabled</a:t>
+              <a:t>–  Read path: resolve vault_user → AppRole login → 60 m tenant token → read</a:t>
             </a:r>
           </a:p>
           <a:p>
@@ -12511,7 +12577,7 @@
                 </a:solidFill>
                 <a:latin typeface="Calibri"/>
               </a:rPr>
-              <a:t>▪  The deployed posture is development-grade</a:t>
+              <a:t>▪  Writing is still owner-gated via OpenFGA can_manage_credentials</a:t>
             </a:r>
           </a:p>
           <a:p>
@@ -12533,7 +12599,29 @@
                 </a:solidFill>
                 <a:latin typeface="Calibri"/>
               </a:rPr>
-              <a:t>–  Single-share unseal (threshold 1), root token on disk, TLS disabled, no audit device</a:t>
+              <a:t>–  Client-supplied credentials are rejected with 403 unless explicitly enabled</a:t>
+            </a:r>
+          </a:p>
+          <a:p>
+            <a:pPr algn="l">
+              <a:lnSpc>
+                <a:spcPct val="122000"/>
+              </a:lnSpc>
+              <a:spcBef>
+                <a:spcPts val="900"/>
+              </a:spcBef>
+              <a:spcAft>
+                <a:spcPts val="300"/>
+              </a:spcAft>
+            </a:pPr>
+            <a:r>
+              <a:rPr sz="1650" b="1">
+                <a:solidFill>
+                  <a:srgbClr val="0F172A"/>
+                </a:solidFill>
+                <a:latin typeface="Calibri"/>
+              </a:rPr>
+              <a:t>▪  Development-grade posture: single-share unseal, root token on disk, TLS disabled</a:t>
             </a:r>
           </a:p>
         </p:txBody>

</xml_diff>